<commit_message>
Extend deck to 12 slides with a dedicated evaluation-metrics slide
New slide 6 defines every metric before the results (AUC/KS, Brier/ECE,
profit, DeLong + bootstrap), per the submission guide's requirement to
define each metric used.

Co-Authored-By: Claude Opus 4.8 <noreply@anthropic.com>
</commit_message>
<xml_diff>
--- a/Project_Video_Presentation.pptx
+++ b/Project_Video_Presentation.pptx
@@ -16,6 +16,7 @@
     <p:sldId id="264" r:id="rId16"/>
     <p:sldId id="265" r:id="rId17"/>
     <p:sldId id="266" r:id="rId18"/>
+    <p:sldId id="267" r:id="rId19"/>
   </p:sldIdLst>
   <p:sldSz cx="12191695" cy="6858000" type="screen4x3"/>
   <p:notesSz cx="6858000" cy="9144000"/>
@@ -582,7 +583,7 @@
           <a:lstStyle/>
           <a:p>
             <a:r>
-              <a:t>Taiwan reproduces the ranking, so it is not a Lending Club artifact. Then the honest limitations: reject inference, simple cash-flow model, platform grades as features, single benign test vintage.</a:t>
+              <a:t>Feature importance vs information value: both models rely on the platform's risk pricing, so all four models largely re-rank loans Lending Club already ranked. The scorecard stays point-readable.</a:t>
             </a:r>
           </a:p>
         </p:txBody>
@@ -652,6 +653,76 @@
           <a:lstStyle/>
           <a:p>
             <a:r>
+              <a:t>Taiwan reproduces the ranking, so it is not a Lending Club artifact. Then the honest limitations: reject inference, simple cash-flow model, platform grades as features, single benign test vintage.</a:t>
+            </a:r>
+          </a:p>
+        </p:txBody>
+      </p:sp>
+      <p:sp>
+        <p:nvSpPr>
+          <p:cNvPr id="4" name="Slide Number Placeholder 3"/>
+          <p:cNvSpPr>
+            <a:spLocks noGrp="1"/>
+          </p:cNvSpPr>
+          <p:nvPr>
+            <p:ph type="sldNum" idx="5" sz="quarter"/>
+          </p:nvPr>
+        </p:nvSpPr>
+        <p:spPr/>
+      </p:sp>
+    </p:spTree>
+  </p:cSld>
+  <p:clrMapOvr>
+    <a:masterClrMapping/>
+  </p:clrMapOvr>
+</p:notes>
+</file>
+
+<file path=ppt/notesSlides/notesSlide12.xml><?xml version="1.0" encoding="utf-8"?>
+<p:notes xmlns:a="http://schemas.openxmlformats.org/drawingml/2006/main" xmlns:p="http://schemas.openxmlformats.org/presentationml/2006/main" xmlns:r="http://schemas.openxmlformats.org/officeDocument/2006/relationships">
+  <p:cSld>
+    <p:spTree>
+      <p:nvGrpSpPr>
+        <p:cNvPr id="1" name=""/>
+        <p:cNvGrpSpPr/>
+        <p:nvPr/>
+      </p:nvGrpSpPr>
+      <p:grpSpPr>
+        <a:xfrm>
+          <a:off x="0" y="0"/>
+          <a:ext cx="0" cy="0"/>
+          <a:chOff x="0" y="0"/>
+          <a:chExt cx="0" cy="0"/>
+        </a:xfrm>
+      </p:grpSpPr>
+      <p:sp>
+        <p:nvSpPr>
+          <p:cNvPr id="2" name="Slide Image Placeholder 1"/>
+          <p:cNvSpPr>
+            <a:spLocks noGrp="1"/>
+          </p:cNvSpPr>
+          <p:nvPr>
+            <p:ph type="sldImg" idx="2"/>
+          </p:nvPr>
+        </p:nvSpPr>
+        <p:spPr/>
+      </p:sp>
+      <p:sp>
+        <p:nvSpPr>
+          <p:cNvPr id="3" name="Notes Placeholder 2"/>
+          <p:cNvSpPr>
+            <a:spLocks noGrp="1"/>
+          </p:cNvSpPr>
+          <p:nvPr>
+            <p:ph type="body" idx="3" sz="quarter"/>
+          </p:nvPr>
+        </p:nvSpPr>
+        <p:spPr/>
+        <p:txBody>
+          <a:bodyPr/>
+          <a:lstStyle/>
+          <a:p>
+            <a:r>
               <a:t>Wrap up: qualified yes. Recap the three criteria, the learnings, and future work. Point to the GitHub repo where everything reproduces with one command. Thank the viewer.</a:t>
             </a:r>
           </a:p>
@@ -1002,7 +1073,7 @@
           <a:lstStyle/>
           <a:p>
             <a:r>
-              <a:t>First results: XGBoost +0.85 AUC points over the scorecard, LightGBM close behind, both overwhelmingly significant by DeLong. The MLP actually loses to the scorecard. Explain why the gap is modest.</a:t>
+              <a:t>Define the metrics before showing numbers: AUC and KS for ranking, Brier and ECE for calibration, realized profit for decisions, with DeLong and bootstrap significance everywhere. The point: the three questions can rank models differently.</a:t>
             </a:r>
           </a:p>
         </p:txBody>
@@ -1072,7 +1143,7 @@
           <a:lstStyle/>
           <a:p>
             <a:r>
-              <a:t>Reliability diagrams: raw curves above the diagonal because of vintage drift. Isotonic recalibration on 2014 removes most but not all bias. Scorecard is the best-calibrated model throughout; this is why regulators monitor rather than trust PD models.</a:t>
+              <a:t>First results: XGBoost +0.85 AUC points over the scorecard, LightGBM close behind, both overwhelmingly significant by DeLong. The MLP actually loses to the scorecard. Explain why the gap is modest.</a:t>
             </a:r>
           </a:p>
         </p:txBody>
@@ -1142,7 +1213,7 @@
           <a:lstStyle/>
           <a:p>
             <a:r>
-              <a:t>Profit curves from actual cash flows. The whole battle happens in the zoomed panel: XGBoost's optimal policy makes 2.1% more than the scorecard's. Modest per applicant, linear in volume.</a:t>
+              <a:t>Reliability diagrams: raw curves above the diagonal because of vintage drift. Isotonic recalibration on 2014 removes most but not all bias. Scorecard is the best-calibrated model throughout; this is why regulators monitor rather than trust PD models.</a:t>
             </a:r>
           </a:p>
         </p:txBody>
@@ -1212,7 +1283,7 @@
           <a:lstStyle/>
           <a:p>
             <a:r>
-              <a:t>Feature importance vs information value: both models rely on the platform's risk pricing, so all four models largely re-rank loans Lending Club already ranked. The scorecard stays point-readable.</a:t>
+              <a:t>Profit curves from actual cash flows. The whole battle happens in the zoomed panel: XGBoost's optimal policy makes 2.1% more than the scorecard's. Modest per applicant, linear in volume.</a:t>
             </a:r>
           </a:p>
         </p:txBody>
@@ -4297,7 +4368,7 @@
                 </a:solidFill>
                 <a:latin typeface="Calibri"/>
               </a:rPr>
-              <a:t>ROBUSTNESS AND LIMITATIONS</a:t>
+              <a:t>RESULTS 4 OF 4</a:t>
             </a:r>
           </a:p>
         </p:txBody>
@@ -4339,57 +4410,35 @@
                 </a:solidFill>
                 <a:latin typeface="Calibri"/>
               </a:rPr>
-              <a:t>Same Ranking on an Independent Dataset</a:t>
-            </a:r>
-          </a:p>
-        </p:txBody>
-      </p:sp>
-      <p:sp>
-        <p:nvSpPr>
-          <p:cNvPr id="4" name="Rounded Rectangle 3"/>
-          <p:cNvSpPr/>
+              <a:t>What Did the Models Learn? Mostly the Same Thing</a:t>
+            </a:r>
+          </a:p>
+        </p:txBody>
+      </p:sp>
+      <p:pic>
+        <p:nvPicPr>
+          <p:cNvPr id="4" name="Picture 3" descr="fig_importance.png"/>
+          <p:cNvPicPr>
+            <a:picLocks noChangeAspect="1"/>
+          </p:cNvPicPr>
           <p:nvPr/>
-        </p:nvSpPr>
-        <p:spPr>
-          <a:xfrm>
-            <a:off x="548640" y="1691640"/>
-            <a:ext cx="5394960" cy="2377440"/>
-          </a:xfrm>
-          <a:prstGeom prst="roundRect">
-            <a:avLst>
-              <a:gd name="adj" fmla="val 8000"/>
-            </a:avLst>
+        </p:nvPicPr>
+        <p:blipFill>
+          <a:blip r:embed="rId2"/>
+          <a:stretch>
+            <a:fillRect/>
+          </a:stretch>
+        </p:blipFill>
+        <p:spPr>
+          <a:xfrm>
+            <a:off x="548640" y="1737360"/>
+            <a:ext cx="7237973" cy="3931920"/>
+          </a:xfrm>
+          <a:prstGeom prst="rect">
+            <a:avLst/>
           </a:prstGeom>
-          <a:solidFill>
-            <a:srgbClr val="EDF1F7"/>
-          </a:solidFill>
-          <a:ln>
-            <a:noFill/>
-          </a:ln>
-          <a:effectLst/>
-        </p:spPr>
-        <p:style>
-          <a:lnRef idx="1">
-            <a:schemeClr val="accent1"/>
-          </a:lnRef>
-          <a:fillRef idx="3">
-            <a:schemeClr val="accent1"/>
-          </a:fillRef>
-          <a:effectRef idx="2">
-            <a:schemeClr val="accent1"/>
-          </a:effectRef>
-          <a:fontRef idx="minor">
-            <a:schemeClr val="lt1"/>
-          </a:fontRef>
-        </p:style>
-        <p:txBody>
-          <a:bodyPr rtlCol="0" anchor="ctr"/>
-          <a:lstStyle/>
-          <a:p>
-            <a:pPr algn="ctr"/>
-          </a:p>
-        </p:txBody>
-      </p:sp>
+        </p:spPr>
+      </p:pic>
       <p:sp>
         <p:nvSpPr>
           <p:cNvPr id="5" name="TextBox 4"/>
@@ -4398,8 +4447,8 @@
         </p:nvSpPr>
         <p:spPr>
           <a:xfrm>
-            <a:off x="822960" y="1874519"/>
-            <a:ext cx="4846320" cy="365760"/>
+            <a:off x="7863840" y="1828800"/>
+            <a:ext cx="3840480" cy="4023360"/>
           </a:xfrm>
           <a:prstGeom prst="rect">
             <a:avLst/>
@@ -4414,62 +4463,48 @@
           <a:p>
             <a:pPr algn="l">
               <a:lnSpc>
-                <a:spcPct val="100000"/>
-              </a:lnSpc>
-              <a:spcAft>
-                <a:spcPts val="600"/>
-              </a:spcAft>
-            </a:pPr>
-            <a:r>
-              <a:rPr sz="1600" b="1" i="0">
+                <a:spcPct val="105000"/>
+              </a:lnSpc>
+              <a:spcAft>
+                <a:spcPts val="1200"/>
+              </a:spcAft>
+            </a:pPr>
+            <a:r>
+              <a:rPr sz="1450" b="1" i="0">
                 <a:solidFill>
                   <a:srgbClr val="1B3A6B"/>
                 </a:solidFill>
                 <a:latin typeface="Calibri"/>
               </a:rPr>
-              <a:t>UCI Taiwan credit-card default (30k clients)</a:t>
-            </a:r>
-          </a:p>
-        </p:txBody>
-      </p:sp>
-      <p:sp>
-        <p:nvSpPr>
-          <p:cNvPr id="6" name="TextBox 5"/>
-          <p:cNvSpPr txBox="1"/>
-          <p:nvPr/>
-        </p:nvSpPr>
-        <p:spPr>
-          <a:xfrm>
-            <a:off x="822960" y="2331720"/>
-            <a:ext cx="4846320" cy="1645920"/>
-          </a:xfrm>
-          <a:prstGeom prst="rect">
-            <a:avLst/>
-          </a:prstGeom>
-          <a:noFill/>
-        </p:spPr>
-        <p:txBody>
-          <a:bodyPr wrap="square" anchor="t" lIns="0" rIns="0" tIns="0" bIns="0">
-            <a:spAutoFit/>
-          </a:bodyPr>
-          <a:lstStyle/>
+              <a:t>Both families agree  </a:t>
+            </a:r>
+            <a:r>
+              <a:rPr sz="1450" b="0" i="0">
+                <a:solidFill>
+                  <a:srgbClr val="212121"/>
+                </a:solidFill>
+                <a:latin typeface="Calibri"/>
+              </a:rPr>
+              <a:t>that the platform's own pricing (interest rate, grade) carries the most signal; rank correlation 0.56.</a:t>
+            </a:r>
+          </a:p>
           <a:p>
             <a:pPr algn="l">
               <a:lnSpc>
-                <a:spcPct val="100000"/>
-              </a:lnSpc>
-              <a:spcAft>
-                <a:spcPts val="1000"/>
+                <a:spcPct val="105000"/>
+              </a:lnSpc>
+              <a:spcAft>
+                <a:spcPts val="1200"/>
               </a:spcAft>
             </a:pPr>
             <a:r>
               <a:rPr sz="1450" b="1" i="0">
                 <a:solidFill>
-                  <a:srgbClr val="1B7A4B"/>
-                </a:solidFill>
-                <a:latin typeface="Calibri"/>
-              </a:rPr>
-              <a:t>XGBoost 0.788</a:t>
+                  <a:srgbClr val="1B3A6B"/>
+                </a:solidFill>
+                <a:latin typeface="Calibri"/>
+              </a:rPr>
+              <a:t>They disagree in encoding:  </a:t>
             </a:r>
             <a:r>
               <a:rPr sz="1450" b="0" i="0">
@@ -4478,26 +4513,26 @@
                 </a:solidFill>
                 <a:latin typeface="Calibri"/>
               </a:rPr>
-              <a:t>  vs scorecard 0.772 AUC: +1.50 pts, p = 2.8×10⁻⁶</a:t>
+              <a:t>the scorecard leans on sub-grade and FICO bins; XGBoost prefers the continuous interest rate and income.</a:t>
             </a:r>
           </a:p>
           <a:p>
             <a:pPr algn="l">
               <a:lnSpc>
-                <a:spcPct val="100000"/>
-              </a:lnSpc>
-              <a:spcAft>
-                <a:spcPts val="1000"/>
+                <a:spcPct val="105000"/>
+              </a:lnSpc>
+              <a:spcAft>
+                <a:spcPts val="1200"/>
               </a:spcAft>
             </a:pPr>
             <a:r>
               <a:rPr sz="1450" b="1" i="0">
                 <a:solidFill>
-                  <a:srgbClr val="A42A2A"/>
-                </a:solidFill>
-                <a:latin typeface="Calibri"/>
-              </a:rPr>
-              <a:t>MLP 0.766</a:t>
+                  <a:srgbClr val="1B3A6B"/>
+                </a:solidFill>
+                <a:latin typeface="Calibri"/>
+              </a:rPr>
+              <a:t>Interpretability trade-off:  </a:t>
             </a:r>
             <a:r>
               <a:rPr sz="1450" b="0" i="0">
@@ -4506,240 +4541,7 @@
                 </a:solidFill>
                 <a:latin typeface="Calibri"/>
               </a:rPr>
-              <a:t>  again below the scorecard</a:t>
-            </a:r>
-          </a:p>
-          <a:p>
-            <a:pPr algn="l">
-              <a:lnSpc>
-                <a:spcPct val="100000"/>
-              </a:lnSpc>
-              <a:spcAft>
-                <a:spcPts val="1000"/>
-              </a:spcAft>
-            </a:pPr>
-            <a:r>
-              <a:rPr sz="1450" b="1" i="0">
-                <a:solidFill>
-                  <a:srgbClr val="1B3A6B"/>
-                </a:solidFill>
-                <a:latin typeface="Calibri"/>
-              </a:rPr>
-              <a:t>Scorecard again best ECE</a:t>
-            </a:r>
-            <a:r>
-              <a:rPr sz="1450" b="0" i="0">
-                <a:solidFill>
-                  <a:srgbClr val="212121"/>
-                </a:solidFill>
-                <a:latin typeface="Calibri"/>
-              </a:rPr>
-              <a:t>  after identical recalibration</a:t>
-            </a:r>
-          </a:p>
-        </p:txBody>
-      </p:sp>
-      <p:sp>
-        <p:nvSpPr>
-          <p:cNvPr id="7" name="TextBox 6"/>
-          <p:cNvSpPr txBox="1"/>
-          <p:nvPr/>
-        </p:nvSpPr>
-        <p:spPr>
-          <a:xfrm>
-            <a:off x="6309360" y="1371600"/>
-            <a:ext cx="5394960" cy="365760"/>
-          </a:xfrm>
-          <a:prstGeom prst="rect">
-            <a:avLst/>
-          </a:prstGeom>
-          <a:noFill/>
-        </p:spPr>
-        <p:txBody>
-          <a:bodyPr wrap="square" anchor="t" lIns="0" rIns="0" tIns="0" bIns="0">
-            <a:spAutoFit/>
-          </a:bodyPr>
-          <a:lstStyle/>
-          <a:p>
-            <a:pPr algn="l">
-              <a:lnSpc>
-                <a:spcPct val="100000"/>
-              </a:lnSpc>
-              <a:spcAft>
-                <a:spcPts val="600"/>
-              </a:spcAft>
-            </a:pPr>
-            <a:r>
-              <a:rPr sz="1600" b="1" i="0">
-                <a:solidFill>
-                  <a:srgbClr val="1B3A6B"/>
-                </a:solidFill>
-                <a:latin typeface="Calibri"/>
-              </a:rPr>
-              <a:t>Honest limitations</a:t>
-            </a:r>
-          </a:p>
-        </p:txBody>
-      </p:sp>
-      <p:sp>
-        <p:nvSpPr>
-          <p:cNvPr id="8" name="TextBox 7"/>
-          <p:cNvSpPr txBox="1"/>
-          <p:nvPr/>
-        </p:nvSpPr>
-        <p:spPr>
-          <a:xfrm>
-            <a:off x="6309360" y="1874519"/>
-            <a:ext cx="5394960" cy="4572000"/>
-          </a:xfrm>
-          <a:prstGeom prst="rect">
-            <a:avLst/>
-          </a:prstGeom>
-          <a:noFill/>
-        </p:spPr>
-        <p:txBody>
-          <a:bodyPr wrap="square" anchor="t" lIns="0" rIns="0" tIns="0" bIns="0">
-            <a:spAutoFit/>
-          </a:bodyPr>
-          <a:lstStyle/>
-          <a:p>
-            <a:pPr algn="l">
-              <a:lnSpc>
-                <a:spcPct val="105000"/>
-              </a:lnSpc>
-              <a:spcAft>
-                <a:spcPts val="900"/>
-              </a:spcAft>
-            </a:pPr>
-            <a:r>
-              <a:rPr sz="1400" b="1" i="0">
-                <a:solidFill>
-                  <a:srgbClr val="1B3A6B"/>
-                </a:solidFill>
-                <a:latin typeface="Calibri"/>
-              </a:rPr>
-              <a:t>Accepted loans only:  </a:t>
-            </a:r>
-            <a:r>
-              <a:rPr sz="1400" b="0" i="0">
-                <a:solidFill>
-                  <a:srgbClr val="212121"/>
-                </a:solidFill>
-                <a:latin typeface="Calibri"/>
-              </a:rPr>
-              <a:t>all models inherit Lending Club's own selection; reject inference is an open problem.</a:t>
-            </a:r>
-          </a:p>
-          <a:p>
-            <a:pPr algn="l">
-              <a:lnSpc>
-                <a:spcPct val="105000"/>
-              </a:lnSpc>
-              <a:spcAft>
-                <a:spcPts val="900"/>
-              </a:spcAft>
-            </a:pPr>
-            <a:r>
-              <a:rPr sz="1400" b="1" i="0">
-                <a:solidFill>
-                  <a:srgbClr val="1B3A6B"/>
-                </a:solidFill>
-                <a:latin typeface="Calibri"/>
-              </a:rPr>
-              <a:t>Simple profit model:  </a:t>
-            </a:r>
-            <a:r>
-              <a:rPr sz="1400" b="0" i="0">
-                <a:solidFill>
-                  <a:srgbClr val="212121"/>
-                </a:solidFill>
-                <a:latin typeface="Calibri"/>
-              </a:rPr>
-              <a:t>undiscounted, fixed LGD of 0.65, no partial recoveries or prepayment.</a:t>
-            </a:r>
-          </a:p>
-          <a:p>
-            <a:pPr algn="l">
-              <a:lnSpc>
-                <a:spcPct val="105000"/>
-              </a:lnSpc>
-              <a:spcAft>
-                <a:spcPts val="900"/>
-              </a:spcAft>
-            </a:pPr>
-            <a:r>
-              <a:rPr sz="1400" b="1" i="0">
-                <a:solidFill>
-                  <a:srgbClr val="1B3A6B"/>
-                </a:solidFill>
-                <a:latin typeface="Calibri"/>
-              </a:rPr>
-              <a:t>Platform grades kept as features:  </a:t>
-            </a:r>
-            <a:r>
-              <a:rPr sz="1400" b="0" i="0">
-                <a:solidFill>
-                  <a:srgbClr val="212121"/>
-                </a:solidFill>
-                <a:latin typeface="Calibri"/>
-              </a:rPr>
-              <a:t>realistic for an investor, but understates what ML could add on raw bureau data.</a:t>
-            </a:r>
-          </a:p>
-          <a:p>
-            <a:pPr algn="l">
-              <a:lnSpc>
-                <a:spcPct val="105000"/>
-              </a:lnSpc>
-              <a:spcAft>
-                <a:spcPts val="900"/>
-              </a:spcAft>
-            </a:pPr>
-            <a:r>
-              <a:rPr sz="1400" b="1" i="0">
-                <a:solidFill>
-                  <a:srgbClr val="1B3A6B"/>
-                </a:solidFill>
-                <a:latin typeface="Calibri"/>
-              </a:rPr>
-              <a:t>One market, one test vintage:  </a:t>
-            </a:r>
-            <a:r>
-              <a:rPr sz="1400" b="0" i="0">
-                <a:solidFill>
-                  <a:srgbClr val="212121"/>
-                </a:solidFill>
-                <a:latin typeface="Calibri"/>
-              </a:rPr>
-              <a:t>2015 was benign; a recession vintage could reorder the calibration findings.</a:t>
-            </a:r>
-          </a:p>
-          <a:p>
-            <a:pPr algn="l">
-              <a:lnSpc>
-                <a:spcPct val="105000"/>
-              </a:lnSpc>
-              <a:spcAft>
-                <a:spcPts val="900"/>
-              </a:spcAft>
-            </a:pPr>
-            <a:r>
-              <a:rPr sz="1400" b="1" i="0">
-                <a:solidFill>
-                  <a:srgbClr val="1B3A6B"/>
-                </a:solidFill>
-                <a:latin typeface="Calibri"/>
-              </a:rPr>
-              <a:t>My scorecard is unconstrained:  </a:t>
-            </a:r>
-            <a:r>
-              <a:rPr sz="1400" b="0" i="0">
-                <a:solidFill>
-                  <a:srgbClr val="212121"/>
-                </a:solidFill>
-                <a:latin typeface="Calibri"/>
-              </a:rPr>
-              <a:t>expert binning with monotonicity constraints would likely close part of the gap.</a:t>
+              <a:t>the scorecard is a readable sum of points per applicant; the ensemble needs post-hoc explanation tools.</a:t>
             </a:r>
           </a:p>
         </p:txBody>
@@ -4764,6 +4566,508 @@
       <p:grpSpPr/>
       <p:sp>
         <p:nvSpPr>
+          <p:cNvPr id="2" name="TextBox 1"/>
+          <p:cNvSpPr txBox="1"/>
+          <p:nvPr/>
+        </p:nvSpPr>
+        <p:spPr>
+          <a:xfrm>
+            <a:off x="548640" y="347472"/>
+            <a:ext cx="11064240" cy="274320"/>
+          </a:xfrm>
+          <a:prstGeom prst="rect">
+            <a:avLst/>
+          </a:prstGeom>
+          <a:noFill/>
+        </p:spPr>
+        <p:txBody>
+          <a:bodyPr wrap="square" anchor="t" lIns="0" rIns="0" tIns="0" bIns="0">
+            <a:spAutoFit/>
+          </a:bodyPr>
+          <a:lstStyle/>
+          <a:p>
+            <a:pPr algn="l">
+              <a:lnSpc>
+                <a:spcPct val="100000"/>
+              </a:lnSpc>
+              <a:spcAft>
+                <a:spcPts val="600"/>
+              </a:spcAft>
+            </a:pPr>
+            <a:r>
+              <a:rPr sz="1300" b="1" i="0">
+                <a:solidFill>
+                  <a:srgbClr val="C99B1C"/>
+                </a:solidFill>
+                <a:latin typeface="Calibri"/>
+              </a:rPr>
+              <a:t>ROBUSTNESS AND LIMITATIONS</a:t>
+            </a:r>
+          </a:p>
+        </p:txBody>
+      </p:sp>
+      <p:sp>
+        <p:nvSpPr>
+          <p:cNvPr id="3" name="TextBox 2"/>
+          <p:cNvSpPr txBox="1"/>
+          <p:nvPr/>
+        </p:nvSpPr>
+        <p:spPr>
+          <a:xfrm>
+            <a:off x="548640" y="621792"/>
+            <a:ext cx="11064240" cy="685800"/>
+          </a:xfrm>
+          <a:prstGeom prst="rect">
+            <a:avLst/>
+          </a:prstGeom>
+          <a:noFill/>
+        </p:spPr>
+        <p:txBody>
+          <a:bodyPr wrap="square" anchor="t" lIns="0" rIns="0" tIns="0" bIns="0">
+            <a:spAutoFit/>
+          </a:bodyPr>
+          <a:lstStyle/>
+          <a:p>
+            <a:pPr algn="l">
+              <a:lnSpc>
+                <a:spcPct val="100000"/>
+              </a:lnSpc>
+              <a:spcAft>
+                <a:spcPts val="600"/>
+              </a:spcAft>
+            </a:pPr>
+            <a:r>
+              <a:rPr sz="3200" b="1" i="0">
+                <a:solidFill>
+                  <a:srgbClr val="1B3A6B"/>
+                </a:solidFill>
+                <a:latin typeface="Calibri"/>
+              </a:rPr>
+              <a:t>Same Ranking on an Independent Dataset</a:t>
+            </a:r>
+          </a:p>
+        </p:txBody>
+      </p:sp>
+      <p:sp>
+        <p:nvSpPr>
+          <p:cNvPr id="4" name="Rounded Rectangle 3"/>
+          <p:cNvSpPr/>
+          <p:nvPr/>
+        </p:nvSpPr>
+        <p:spPr>
+          <a:xfrm>
+            <a:off x="548640" y="1691640"/>
+            <a:ext cx="5394960" cy="2377440"/>
+          </a:xfrm>
+          <a:prstGeom prst="roundRect">
+            <a:avLst>
+              <a:gd name="adj" fmla="val 8000"/>
+            </a:avLst>
+          </a:prstGeom>
+          <a:solidFill>
+            <a:srgbClr val="EDF1F7"/>
+          </a:solidFill>
+          <a:ln>
+            <a:noFill/>
+          </a:ln>
+          <a:effectLst/>
+        </p:spPr>
+        <p:style>
+          <a:lnRef idx="1">
+            <a:schemeClr val="accent1"/>
+          </a:lnRef>
+          <a:fillRef idx="3">
+            <a:schemeClr val="accent1"/>
+          </a:fillRef>
+          <a:effectRef idx="2">
+            <a:schemeClr val="accent1"/>
+          </a:effectRef>
+          <a:fontRef idx="minor">
+            <a:schemeClr val="lt1"/>
+          </a:fontRef>
+        </p:style>
+        <p:txBody>
+          <a:bodyPr rtlCol="0" anchor="ctr"/>
+          <a:lstStyle/>
+          <a:p>
+            <a:pPr algn="ctr"/>
+          </a:p>
+        </p:txBody>
+      </p:sp>
+      <p:sp>
+        <p:nvSpPr>
+          <p:cNvPr id="5" name="TextBox 4"/>
+          <p:cNvSpPr txBox="1"/>
+          <p:nvPr/>
+        </p:nvSpPr>
+        <p:spPr>
+          <a:xfrm>
+            <a:off x="822960" y="1874519"/>
+            <a:ext cx="4846320" cy="365760"/>
+          </a:xfrm>
+          <a:prstGeom prst="rect">
+            <a:avLst/>
+          </a:prstGeom>
+          <a:noFill/>
+        </p:spPr>
+        <p:txBody>
+          <a:bodyPr wrap="square" anchor="t" lIns="0" rIns="0" tIns="0" bIns="0">
+            <a:spAutoFit/>
+          </a:bodyPr>
+          <a:lstStyle/>
+          <a:p>
+            <a:pPr algn="l">
+              <a:lnSpc>
+                <a:spcPct val="100000"/>
+              </a:lnSpc>
+              <a:spcAft>
+                <a:spcPts val="600"/>
+              </a:spcAft>
+            </a:pPr>
+            <a:r>
+              <a:rPr sz="1600" b="1" i="0">
+                <a:solidFill>
+                  <a:srgbClr val="1B3A6B"/>
+                </a:solidFill>
+                <a:latin typeface="Calibri"/>
+              </a:rPr>
+              <a:t>UCI Taiwan credit-card default (30k clients)</a:t>
+            </a:r>
+          </a:p>
+        </p:txBody>
+      </p:sp>
+      <p:sp>
+        <p:nvSpPr>
+          <p:cNvPr id="6" name="TextBox 5"/>
+          <p:cNvSpPr txBox="1"/>
+          <p:nvPr/>
+        </p:nvSpPr>
+        <p:spPr>
+          <a:xfrm>
+            <a:off x="822960" y="2331720"/>
+            <a:ext cx="4846320" cy="1645920"/>
+          </a:xfrm>
+          <a:prstGeom prst="rect">
+            <a:avLst/>
+          </a:prstGeom>
+          <a:noFill/>
+        </p:spPr>
+        <p:txBody>
+          <a:bodyPr wrap="square" anchor="t" lIns="0" rIns="0" tIns="0" bIns="0">
+            <a:spAutoFit/>
+          </a:bodyPr>
+          <a:lstStyle/>
+          <a:p>
+            <a:pPr algn="l">
+              <a:lnSpc>
+                <a:spcPct val="100000"/>
+              </a:lnSpc>
+              <a:spcAft>
+                <a:spcPts val="1000"/>
+              </a:spcAft>
+            </a:pPr>
+            <a:r>
+              <a:rPr sz="1450" b="1" i="0">
+                <a:solidFill>
+                  <a:srgbClr val="1B7A4B"/>
+                </a:solidFill>
+                <a:latin typeface="Calibri"/>
+              </a:rPr>
+              <a:t>XGBoost 0.788</a:t>
+            </a:r>
+            <a:r>
+              <a:rPr sz="1450" b="0" i="0">
+                <a:solidFill>
+                  <a:srgbClr val="212121"/>
+                </a:solidFill>
+                <a:latin typeface="Calibri"/>
+              </a:rPr>
+              <a:t>  vs scorecard 0.772 AUC: +1.50 pts, p = 2.8×10⁻⁶</a:t>
+            </a:r>
+          </a:p>
+          <a:p>
+            <a:pPr algn="l">
+              <a:lnSpc>
+                <a:spcPct val="100000"/>
+              </a:lnSpc>
+              <a:spcAft>
+                <a:spcPts val="1000"/>
+              </a:spcAft>
+            </a:pPr>
+            <a:r>
+              <a:rPr sz="1450" b="1" i="0">
+                <a:solidFill>
+                  <a:srgbClr val="A42A2A"/>
+                </a:solidFill>
+                <a:latin typeface="Calibri"/>
+              </a:rPr>
+              <a:t>MLP 0.766</a:t>
+            </a:r>
+            <a:r>
+              <a:rPr sz="1450" b="0" i="0">
+                <a:solidFill>
+                  <a:srgbClr val="212121"/>
+                </a:solidFill>
+                <a:latin typeface="Calibri"/>
+              </a:rPr>
+              <a:t>  again below the scorecard</a:t>
+            </a:r>
+          </a:p>
+          <a:p>
+            <a:pPr algn="l">
+              <a:lnSpc>
+                <a:spcPct val="100000"/>
+              </a:lnSpc>
+              <a:spcAft>
+                <a:spcPts val="1000"/>
+              </a:spcAft>
+            </a:pPr>
+            <a:r>
+              <a:rPr sz="1450" b="1" i="0">
+                <a:solidFill>
+                  <a:srgbClr val="1B3A6B"/>
+                </a:solidFill>
+                <a:latin typeface="Calibri"/>
+              </a:rPr>
+              <a:t>Scorecard again best ECE</a:t>
+            </a:r>
+            <a:r>
+              <a:rPr sz="1450" b="0" i="0">
+                <a:solidFill>
+                  <a:srgbClr val="212121"/>
+                </a:solidFill>
+                <a:latin typeface="Calibri"/>
+              </a:rPr>
+              <a:t>  after identical recalibration</a:t>
+            </a:r>
+          </a:p>
+        </p:txBody>
+      </p:sp>
+      <p:sp>
+        <p:nvSpPr>
+          <p:cNvPr id="7" name="TextBox 6"/>
+          <p:cNvSpPr txBox="1"/>
+          <p:nvPr/>
+        </p:nvSpPr>
+        <p:spPr>
+          <a:xfrm>
+            <a:off x="6309360" y="1371600"/>
+            <a:ext cx="5394960" cy="365760"/>
+          </a:xfrm>
+          <a:prstGeom prst="rect">
+            <a:avLst/>
+          </a:prstGeom>
+          <a:noFill/>
+        </p:spPr>
+        <p:txBody>
+          <a:bodyPr wrap="square" anchor="t" lIns="0" rIns="0" tIns="0" bIns="0">
+            <a:spAutoFit/>
+          </a:bodyPr>
+          <a:lstStyle/>
+          <a:p>
+            <a:pPr algn="l">
+              <a:lnSpc>
+                <a:spcPct val="100000"/>
+              </a:lnSpc>
+              <a:spcAft>
+                <a:spcPts val="600"/>
+              </a:spcAft>
+            </a:pPr>
+            <a:r>
+              <a:rPr sz="1600" b="1" i="0">
+                <a:solidFill>
+                  <a:srgbClr val="1B3A6B"/>
+                </a:solidFill>
+                <a:latin typeface="Calibri"/>
+              </a:rPr>
+              <a:t>Honest limitations</a:t>
+            </a:r>
+          </a:p>
+        </p:txBody>
+      </p:sp>
+      <p:sp>
+        <p:nvSpPr>
+          <p:cNvPr id="8" name="TextBox 7"/>
+          <p:cNvSpPr txBox="1"/>
+          <p:nvPr/>
+        </p:nvSpPr>
+        <p:spPr>
+          <a:xfrm>
+            <a:off x="6309360" y="1874519"/>
+            <a:ext cx="5394960" cy="4572000"/>
+          </a:xfrm>
+          <a:prstGeom prst="rect">
+            <a:avLst/>
+          </a:prstGeom>
+          <a:noFill/>
+        </p:spPr>
+        <p:txBody>
+          <a:bodyPr wrap="square" anchor="t" lIns="0" rIns="0" tIns="0" bIns="0">
+            <a:spAutoFit/>
+          </a:bodyPr>
+          <a:lstStyle/>
+          <a:p>
+            <a:pPr algn="l">
+              <a:lnSpc>
+                <a:spcPct val="105000"/>
+              </a:lnSpc>
+              <a:spcAft>
+                <a:spcPts val="900"/>
+              </a:spcAft>
+            </a:pPr>
+            <a:r>
+              <a:rPr sz="1400" b="1" i="0">
+                <a:solidFill>
+                  <a:srgbClr val="1B3A6B"/>
+                </a:solidFill>
+                <a:latin typeface="Calibri"/>
+              </a:rPr>
+              <a:t>Accepted loans only:  </a:t>
+            </a:r>
+            <a:r>
+              <a:rPr sz="1400" b="0" i="0">
+                <a:solidFill>
+                  <a:srgbClr val="212121"/>
+                </a:solidFill>
+                <a:latin typeface="Calibri"/>
+              </a:rPr>
+              <a:t>all models inherit Lending Club's own selection; reject inference is an open problem.</a:t>
+            </a:r>
+          </a:p>
+          <a:p>
+            <a:pPr algn="l">
+              <a:lnSpc>
+                <a:spcPct val="105000"/>
+              </a:lnSpc>
+              <a:spcAft>
+                <a:spcPts val="900"/>
+              </a:spcAft>
+            </a:pPr>
+            <a:r>
+              <a:rPr sz="1400" b="1" i="0">
+                <a:solidFill>
+                  <a:srgbClr val="1B3A6B"/>
+                </a:solidFill>
+                <a:latin typeface="Calibri"/>
+              </a:rPr>
+              <a:t>Simple profit model:  </a:t>
+            </a:r>
+            <a:r>
+              <a:rPr sz="1400" b="0" i="0">
+                <a:solidFill>
+                  <a:srgbClr val="212121"/>
+                </a:solidFill>
+                <a:latin typeface="Calibri"/>
+              </a:rPr>
+              <a:t>undiscounted, fixed LGD of 0.65, no partial recoveries or prepayment.</a:t>
+            </a:r>
+          </a:p>
+          <a:p>
+            <a:pPr algn="l">
+              <a:lnSpc>
+                <a:spcPct val="105000"/>
+              </a:lnSpc>
+              <a:spcAft>
+                <a:spcPts val="900"/>
+              </a:spcAft>
+            </a:pPr>
+            <a:r>
+              <a:rPr sz="1400" b="1" i="0">
+                <a:solidFill>
+                  <a:srgbClr val="1B3A6B"/>
+                </a:solidFill>
+                <a:latin typeface="Calibri"/>
+              </a:rPr>
+              <a:t>Platform grades kept as features:  </a:t>
+            </a:r>
+            <a:r>
+              <a:rPr sz="1400" b="0" i="0">
+                <a:solidFill>
+                  <a:srgbClr val="212121"/>
+                </a:solidFill>
+                <a:latin typeface="Calibri"/>
+              </a:rPr>
+              <a:t>realistic for an investor, but understates what ML could add on raw bureau data.</a:t>
+            </a:r>
+          </a:p>
+          <a:p>
+            <a:pPr algn="l">
+              <a:lnSpc>
+                <a:spcPct val="105000"/>
+              </a:lnSpc>
+              <a:spcAft>
+                <a:spcPts val="900"/>
+              </a:spcAft>
+            </a:pPr>
+            <a:r>
+              <a:rPr sz="1400" b="1" i="0">
+                <a:solidFill>
+                  <a:srgbClr val="1B3A6B"/>
+                </a:solidFill>
+                <a:latin typeface="Calibri"/>
+              </a:rPr>
+              <a:t>One market, one test vintage:  </a:t>
+            </a:r>
+            <a:r>
+              <a:rPr sz="1400" b="0" i="0">
+                <a:solidFill>
+                  <a:srgbClr val="212121"/>
+                </a:solidFill>
+                <a:latin typeface="Calibri"/>
+              </a:rPr>
+              <a:t>2015 was benign; a recession vintage could reorder the calibration findings.</a:t>
+            </a:r>
+          </a:p>
+          <a:p>
+            <a:pPr algn="l">
+              <a:lnSpc>
+                <a:spcPct val="105000"/>
+              </a:lnSpc>
+              <a:spcAft>
+                <a:spcPts val="900"/>
+              </a:spcAft>
+            </a:pPr>
+            <a:r>
+              <a:rPr sz="1400" b="1" i="0">
+                <a:solidFill>
+                  <a:srgbClr val="1B3A6B"/>
+                </a:solidFill>
+                <a:latin typeface="Calibri"/>
+              </a:rPr>
+              <a:t>My scorecard is unconstrained:  </a:t>
+            </a:r>
+            <a:r>
+              <a:rPr sz="1400" b="0" i="0">
+                <a:solidFill>
+                  <a:srgbClr val="212121"/>
+                </a:solidFill>
+                <a:latin typeface="Calibri"/>
+              </a:rPr>
+              <a:t>expert binning with monotonicity constraints would likely close part of the gap.</a:t>
+            </a:r>
+          </a:p>
+        </p:txBody>
+      </p:sp>
+    </p:spTree>
+  </p:cSld>
+  <p:clrMapOvr>
+    <a:masterClrMapping/>
+  </p:clrMapOvr>
+</p:sld>
+</file>
+
+<file path=ppt/slides/slide12.xml><?xml version="1.0" encoding="utf-8"?>
+<p:sld xmlns:a="http://schemas.openxmlformats.org/drawingml/2006/main" xmlns:p="http://schemas.openxmlformats.org/presentationml/2006/main" xmlns:r="http://schemas.openxmlformats.org/officeDocument/2006/relationships">
+  <p:cSld>
+    <p:spTree>
+      <p:nvGrpSpPr>
+        <p:cNvPr id="1" name=""/>
+        <p:cNvGrpSpPr/>
+        <p:nvPr/>
+      </p:nvGrpSpPr>
+      <p:grpSpPr/>
+      <p:sp>
+        <p:nvSpPr>
           <p:cNvPr id="2" name="Rectangle 1"/>
           <p:cNvSpPr/>
           <p:nvPr/>
@@ -7735,6 +8039,549 @@
 </file>
 
 <file path=ppt/slides/slide6.xml><?xml version="1.0" encoding="utf-8"?>
+<p:sld xmlns:a="http://schemas.openxmlformats.org/drawingml/2006/main" xmlns:p="http://schemas.openxmlformats.org/presentationml/2006/main" xmlns:r="http://schemas.openxmlformats.org/officeDocument/2006/relationships">
+  <p:cSld>
+    <p:spTree>
+      <p:nvGrpSpPr>
+        <p:cNvPr id="1" name=""/>
+        <p:cNvGrpSpPr/>
+        <p:nvPr/>
+      </p:nvGrpSpPr>
+      <p:grpSpPr/>
+      <p:sp>
+        <p:nvSpPr>
+          <p:cNvPr id="2" name="TextBox 1"/>
+          <p:cNvSpPr txBox="1"/>
+          <p:nvPr/>
+        </p:nvSpPr>
+        <p:spPr>
+          <a:xfrm>
+            <a:off x="548640" y="347472"/>
+            <a:ext cx="11064240" cy="274320"/>
+          </a:xfrm>
+          <a:prstGeom prst="rect">
+            <a:avLst/>
+          </a:prstGeom>
+          <a:noFill/>
+        </p:spPr>
+        <p:txBody>
+          <a:bodyPr wrap="square" anchor="t" lIns="0" rIns="0" tIns="0" bIns="0">
+            <a:spAutoFit/>
+          </a:bodyPr>
+          <a:lstStyle/>
+          <a:p>
+            <a:pPr algn="l">
+              <a:lnSpc>
+                <a:spcPct val="100000"/>
+              </a:lnSpc>
+              <a:spcAft>
+                <a:spcPts val="600"/>
+              </a:spcAft>
+            </a:pPr>
+            <a:r>
+              <a:rPr sz="1300" b="1" i="0">
+                <a:solidFill>
+                  <a:srgbClr val="C99B1C"/>
+                </a:solidFill>
+                <a:latin typeface="Calibri"/>
+              </a:rPr>
+              <a:t>EVALUATION</a:t>
+            </a:r>
+          </a:p>
+        </p:txBody>
+      </p:sp>
+      <p:sp>
+        <p:nvSpPr>
+          <p:cNvPr id="3" name="TextBox 2"/>
+          <p:cNvSpPr txBox="1"/>
+          <p:nvPr/>
+        </p:nvSpPr>
+        <p:spPr>
+          <a:xfrm>
+            <a:off x="548640" y="621792"/>
+            <a:ext cx="11064240" cy="685800"/>
+          </a:xfrm>
+          <a:prstGeom prst="rect">
+            <a:avLst/>
+          </a:prstGeom>
+          <a:noFill/>
+        </p:spPr>
+        <p:txBody>
+          <a:bodyPr wrap="square" anchor="t" lIns="0" rIns="0" tIns="0" bIns="0">
+            <a:spAutoFit/>
+          </a:bodyPr>
+          <a:lstStyle/>
+          <a:p>
+            <a:pPr algn="l">
+              <a:lnSpc>
+                <a:spcPct val="100000"/>
+              </a:lnSpc>
+              <a:spcAft>
+                <a:spcPts val="600"/>
+              </a:spcAft>
+            </a:pPr>
+            <a:r>
+              <a:rPr sz="3200" b="1" i="0">
+                <a:solidFill>
+                  <a:srgbClr val="1B3A6B"/>
+                </a:solidFill>
+                <a:latin typeface="Calibri"/>
+              </a:rPr>
+              <a:t>Three Questions, Each With Its Own Metrics</a:t>
+            </a:r>
+          </a:p>
+        </p:txBody>
+      </p:sp>
+      <p:sp>
+        <p:nvSpPr>
+          <p:cNvPr id="4" name="Rounded Rectangle 3"/>
+          <p:cNvSpPr/>
+          <p:nvPr/>
+        </p:nvSpPr>
+        <p:spPr>
+          <a:xfrm>
+            <a:off x="548640" y="1737360"/>
+            <a:ext cx="11064240" cy="1234440"/>
+          </a:xfrm>
+          <a:prstGeom prst="roundRect">
+            <a:avLst>
+              <a:gd name="adj" fmla="val 8000"/>
+            </a:avLst>
+          </a:prstGeom>
+          <a:solidFill>
+            <a:srgbClr val="EDF1F7"/>
+          </a:solidFill>
+          <a:ln>
+            <a:noFill/>
+          </a:ln>
+          <a:effectLst/>
+        </p:spPr>
+        <p:style>
+          <a:lnRef idx="1">
+            <a:schemeClr val="accent1"/>
+          </a:lnRef>
+          <a:fillRef idx="3">
+            <a:schemeClr val="accent1"/>
+          </a:fillRef>
+          <a:effectRef idx="2">
+            <a:schemeClr val="accent1"/>
+          </a:effectRef>
+          <a:fontRef idx="minor">
+            <a:schemeClr val="lt1"/>
+          </a:fontRef>
+        </p:style>
+        <p:txBody>
+          <a:bodyPr rtlCol="0" anchor="ctr"/>
+          <a:lstStyle/>
+          <a:p>
+            <a:pPr algn="ctr"/>
+          </a:p>
+        </p:txBody>
+      </p:sp>
+      <p:sp>
+        <p:nvSpPr>
+          <p:cNvPr id="5" name="TextBox 4"/>
+          <p:cNvSpPr txBox="1"/>
+          <p:nvPr/>
+        </p:nvSpPr>
+        <p:spPr>
+          <a:xfrm>
+            <a:off x="868680" y="1883664"/>
+            <a:ext cx="3200400" cy="960120"/>
+          </a:xfrm>
+          <a:prstGeom prst="rect">
+            <a:avLst/>
+          </a:prstGeom>
+          <a:noFill/>
+        </p:spPr>
+        <p:txBody>
+          <a:bodyPr wrap="square" anchor="t" lIns="0" rIns="0" tIns="0" bIns="0">
+            <a:spAutoFit/>
+          </a:bodyPr>
+          <a:lstStyle/>
+          <a:p>
+            <a:pPr algn="l">
+              <a:lnSpc>
+                <a:spcPct val="100000"/>
+              </a:lnSpc>
+              <a:spcAft>
+                <a:spcPts val="600"/>
+              </a:spcAft>
+            </a:pPr>
+            <a:r>
+              <a:rPr sz="1650" b="1" i="0">
+                <a:solidFill>
+                  <a:srgbClr val="1B3A6B"/>
+                </a:solidFill>
+                <a:latin typeface="Calibri"/>
+              </a:rPr>
+              <a:t>Discrimination: AUC, KS</a:t>
+            </a:r>
+          </a:p>
+        </p:txBody>
+      </p:sp>
+      <p:sp>
+        <p:nvSpPr>
+          <p:cNvPr id="6" name="TextBox 5"/>
+          <p:cNvSpPr txBox="1"/>
+          <p:nvPr/>
+        </p:nvSpPr>
+        <p:spPr>
+          <a:xfrm>
+            <a:off x="4206240" y="1865376"/>
+            <a:ext cx="7040880" cy="1005840"/>
+          </a:xfrm>
+          <a:prstGeom prst="rect">
+            <a:avLst/>
+          </a:prstGeom>
+          <a:noFill/>
+        </p:spPr>
+        <p:txBody>
+          <a:bodyPr wrap="square" anchor="t" lIns="0" rIns="0" tIns="0" bIns="0">
+            <a:spAutoFit/>
+          </a:bodyPr>
+          <a:lstStyle/>
+          <a:p>
+            <a:pPr algn="l">
+              <a:lnSpc>
+                <a:spcPct val="100000"/>
+              </a:lnSpc>
+              <a:spcAft>
+                <a:spcPts val="600"/>
+              </a:spcAft>
+            </a:pPr>
+            <a:r>
+              <a:rPr sz="1350" b="0" i="0">
+                <a:solidFill>
+                  <a:srgbClr val="212121"/>
+                </a:solidFill>
+                <a:latin typeface="Calibri"/>
+              </a:rPr>
+              <a:t>AUC: probability a random defaulter is ranked riskier than a random good borrower. KS: maximum distance between the two score distributions. Both ignore whether the PD values themselves are right.</a:t>
+            </a:r>
+          </a:p>
+        </p:txBody>
+      </p:sp>
+      <p:sp>
+        <p:nvSpPr>
+          <p:cNvPr id="7" name="Rounded Rectangle 6"/>
+          <p:cNvSpPr/>
+          <p:nvPr/>
+        </p:nvSpPr>
+        <p:spPr>
+          <a:xfrm>
+            <a:off x="548640" y="3154680"/>
+            <a:ext cx="11064240" cy="1234440"/>
+          </a:xfrm>
+          <a:prstGeom prst="roundRect">
+            <a:avLst>
+              <a:gd name="adj" fmla="val 8000"/>
+            </a:avLst>
+          </a:prstGeom>
+          <a:solidFill>
+            <a:srgbClr val="EDF1F7"/>
+          </a:solidFill>
+          <a:ln>
+            <a:noFill/>
+          </a:ln>
+          <a:effectLst/>
+        </p:spPr>
+        <p:style>
+          <a:lnRef idx="1">
+            <a:schemeClr val="accent1"/>
+          </a:lnRef>
+          <a:fillRef idx="3">
+            <a:schemeClr val="accent1"/>
+          </a:fillRef>
+          <a:effectRef idx="2">
+            <a:schemeClr val="accent1"/>
+          </a:effectRef>
+          <a:fontRef idx="minor">
+            <a:schemeClr val="lt1"/>
+          </a:fontRef>
+        </p:style>
+        <p:txBody>
+          <a:bodyPr rtlCol="0" anchor="ctr"/>
+          <a:lstStyle/>
+          <a:p>
+            <a:pPr algn="ctr"/>
+          </a:p>
+        </p:txBody>
+      </p:sp>
+      <p:sp>
+        <p:nvSpPr>
+          <p:cNvPr id="8" name="TextBox 7"/>
+          <p:cNvSpPr txBox="1"/>
+          <p:nvPr/>
+        </p:nvSpPr>
+        <p:spPr>
+          <a:xfrm>
+            <a:off x="868680" y="3300984"/>
+            <a:ext cx="3200400" cy="960120"/>
+          </a:xfrm>
+          <a:prstGeom prst="rect">
+            <a:avLst/>
+          </a:prstGeom>
+          <a:noFill/>
+        </p:spPr>
+        <p:txBody>
+          <a:bodyPr wrap="square" anchor="t" lIns="0" rIns="0" tIns="0" bIns="0">
+            <a:spAutoFit/>
+          </a:bodyPr>
+          <a:lstStyle/>
+          <a:p>
+            <a:pPr algn="l">
+              <a:lnSpc>
+                <a:spcPct val="100000"/>
+              </a:lnSpc>
+              <a:spcAft>
+                <a:spcPts val="600"/>
+              </a:spcAft>
+            </a:pPr>
+            <a:r>
+              <a:rPr sz="1650" b="1" i="0">
+                <a:solidFill>
+                  <a:srgbClr val="1B3A6B"/>
+                </a:solidFill>
+                <a:latin typeface="Calibri"/>
+              </a:rPr>
+              <a:t>Calibration: Brier, ECE, reliability</a:t>
+            </a:r>
+          </a:p>
+        </p:txBody>
+      </p:sp>
+      <p:sp>
+        <p:nvSpPr>
+          <p:cNvPr id="9" name="TextBox 8"/>
+          <p:cNvSpPr txBox="1"/>
+          <p:nvPr/>
+        </p:nvSpPr>
+        <p:spPr>
+          <a:xfrm>
+            <a:off x="4206240" y="3282696"/>
+            <a:ext cx="7040880" cy="1005840"/>
+          </a:xfrm>
+          <a:prstGeom prst="rect">
+            <a:avLst/>
+          </a:prstGeom>
+          <a:noFill/>
+        </p:spPr>
+        <p:txBody>
+          <a:bodyPr wrap="square" anchor="t" lIns="0" rIns="0" tIns="0" bIns="0">
+            <a:spAutoFit/>
+          </a:bodyPr>
+          <a:lstStyle/>
+          <a:p>
+            <a:pPr algn="l">
+              <a:lnSpc>
+                <a:spcPct val="100000"/>
+              </a:lnSpc>
+              <a:spcAft>
+                <a:spcPts val="600"/>
+              </a:spcAft>
+            </a:pPr>
+            <a:r>
+              <a:rPr sz="1350" b="0" i="0">
+                <a:solidFill>
+                  <a:srgbClr val="212121"/>
+                </a:solidFill>
+                <a:latin typeface="Calibri"/>
+              </a:rPr>
+              <a:t>Among loans assigned PD near q, do a fraction q actually default? Brier: mean squared error of the probability. ECE: average gap between predicted PD and observed default rate over 10 bins.</a:t>
+            </a:r>
+          </a:p>
+        </p:txBody>
+      </p:sp>
+      <p:sp>
+        <p:nvSpPr>
+          <p:cNvPr id="10" name="Rounded Rectangle 9"/>
+          <p:cNvSpPr/>
+          <p:nvPr/>
+        </p:nvSpPr>
+        <p:spPr>
+          <a:xfrm>
+            <a:off x="548640" y="4572000"/>
+            <a:ext cx="11064240" cy="1234440"/>
+          </a:xfrm>
+          <a:prstGeom prst="roundRect">
+            <a:avLst>
+              <a:gd name="adj" fmla="val 8000"/>
+            </a:avLst>
+          </a:prstGeom>
+          <a:solidFill>
+            <a:srgbClr val="EDF1F7"/>
+          </a:solidFill>
+          <a:ln>
+            <a:noFill/>
+          </a:ln>
+          <a:effectLst/>
+        </p:spPr>
+        <p:style>
+          <a:lnRef idx="1">
+            <a:schemeClr val="accent1"/>
+          </a:lnRef>
+          <a:fillRef idx="3">
+            <a:schemeClr val="accent1"/>
+          </a:fillRef>
+          <a:effectRef idx="2">
+            <a:schemeClr val="accent1"/>
+          </a:effectRef>
+          <a:fontRef idx="minor">
+            <a:schemeClr val="lt1"/>
+          </a:fontRef>
+        </p:style>
+        <p:txBody>
+          <a:bodyPr rtlCol="0" anchor="ctr"/>
+          <a:lstStyle/>
+          <a:p>
+            <a:pPr algn="ctr"/>
+          </a:p>
+        </p:txBody>
+      </p:sp>
+      <p:sp>
+        <p:nvSpPr>
+          <p:cNvPr id="11" name="TextBox 10"/>
+          <p:cNvSpPr txBox="1"/>
+          <p:nvPr/>
+        </p:nvSpPr>
+        <p:spPr>
+          <a:xfrm>
+            <a:off x="868680" y="4718304"/>
+            <a:ext cx="3200400" cy="960120"/>
+          </a:xfrm>
+          <a:prstGeom prst="rect">
+            <a:avLst/>
+          </a:prstGeom>
+          <a:noFill/>
+        </p:spPr>
+        <p:txBody>
+          <a:bodyPr wrap="square" anchor="t" lIns="0" rIns="0" tIns="0" bIns="0">
+            <a:spAutoFit/>
+          </a:bodyPr>
+          <a:lstStyle/>
+          <a:p>
+            <a:pPr algn="l">
+              <a:lnSpc>
+                <a:spcPct val="100000"/>
+              </a:lnSpc>
+              <a:spcAft>
+                <a:spcPts val="600"/>
+              </a:spcAft>
+            </a:pPr>
+            <a:r>
+              <a:rPr sz="1650" b="1" i="0">
+                <a:solidFill>
+                  <a:srgbClr val="1B3A6B"/>
+                </a:solidFill>
+                <a:latin typeface="Calibri"/>
+              </a:rPr>
+              <a:t>Decision quality: profit, with significance</a:t>
+            </a:r>
+          </a:p>
+        </p:txBody>
+      </p:sp>
+      <p:sp>
+        <p:nvSpPr>
+          <p:cNvPr id="12" name="TextBox 11"/>
+          <p:cNvSpPr txBox="1"/>
+          <p:nvPr/>
+        </p:nvSpPr>
+        <p:spPr>
+          <a:xfrm>
+            <a:off x="4206240" y="4700016"/>
+            <a:ext cx="7040880" cy="1005840"/>
+          </a:xfrm>
+          <a:prstGeom prst="rect">
+            <a:avLst/>
+          </a:prstGeom>
+          <a:noFill/>
+        </p:spPr>
+        <p:txBody>
+          <a:bodyPr wrap="square" anchor="t" lIns="0" rIns="0" tIns="0" bIns="0">
+            <a:spAutoFit/>
+          </a:bodyPr>
+          <a:lstStyle/>
+          <a:p>
+            <a:pPr algn="l">
+              <a:lnSpc>
+                <a:spcPct val="100000"/>
+              </a:lnSpc>
+              <a:spcAft>
+                <a:spcPts val="600"/>
+              </a:spcAft>
+            </a:pPr>
+            <a:r>
+              <a:rPr sz="1350" b="0" i="0">
+                <a:solidFill>
+                  <a:srgbClr val="212121"/>
+                </a:solidFill>
+                <a:latin typeface="Calibri"/>
+              </a:rPr>
+              <a:t>Realized profit per 1,000 applicants across accept/reject cutoffs, from actual cash flows. Significance throughout: DeLong test for correlated AUCs, 1,000-resample bootstrap CIs.</a:t>
+            </a:r>
+          </a:p>
+        </p:txBody>
+      </p:sp>
+      <p:sp>
+        <p:nvSpPr>
+          <p:cNvPr id="13" name="TextBox 12"/>
+          <p:cNvSpPr txBox="1"/>
+          <p:nvPr/>
+        </p:nvSpPr>
+        <p:spPr>
+          <a:xfrm>
+            <a:off x="548640" y="6126480"/>
+            <a:ext cx="11064240" cy="457200"/>
+          </a:xfrm>
+          <a:prstGeom prst="rect">
+            <a:avLst/>
+          </a:prstGeom>
+          <a:noFill/>
+        </p:spPr>
+        <p:txBody>
+          <a:bodyPr wrap="square" anchor="t" lIns="0" rIns="0" tIns="0" bIns="0">
+            <a:spAutoFit/>
+          </a:bodyPr>
+          <a:lstStyle/>
+          <a:p>
+            <a:pPr algn="l">
+              <a:lnSpc>
+                <a:spcPct val="100000"/>
+              </a:lnSpc>
+              <a:spcAft>
+                <a:spcPts val="600"/>
+              </a:spcAft>
+            </a:pPr>
+            <a:r>
+              <a:rPr sz="1500" b="1" i="0">
+                <a:solidFill>
+                  <a:srgbClr val="1B3A6B"/>
+                </a:solidFill>
+                <a:latin typeface="Calibri"/>
+              </a:rPr>
+              <a:t>Why three?  </a:t>
+            </a:r>
+            <a:r>
+              <a:rPr sz="1500" b="0" i="0">
+                <a:solidFill>
+                  <a:srgbClr val="212121"/>
+                </a:solidFill>
+                <a:latin typeface="Calibri"/>
+              </a:rPr>
+              <a:t>A model can gain AUC while its probabilities become less trustworthy; 'best model' is undefined until the question is fixed.</a:t>
+            </a:r>
+          </a:p>
+        </p:txBody>
+      </p:sp>
+    </p:spTree>
+  </p:cSld>
+  <p:clrMapOvr>
+    <a:masterClrMapping/>
+  </p:clrMapOvr>
+</p:sld>
+</file>
+
+<file path=ppt/slides/slide7.xml><?xml version="1.0" encoding="utf-8"?>
 <p:sld xmlns:a="http://schemas.openxmlformats.org/drawingml/2006/main" xmlns:p="http://schemas.openxmlformats.org/presentationml/2006/main" xmlns:r="http://schemas.openxmlformats.org/officeDocument/2006/relationships">
   <p:cSld>
     <p:spTree>
@@ -8472,7 +9319,7 @@
 </p:sld>
 </file>
 
-<file path=ppt/slides/slide7.xml><?xml version="1.0" encoding="utf-8"?>
+<file path=ppt/slides/slide8.xml><?xml version="1.0" encoding="utf-8"?>
 <p:sld xmlns:a="http://schemas.openxmlformats.org/drawingml/2006/main" xmlns:p="http://schemas.openxmlformats.org/presentationml/2006/main" xmlns:r="http://schemas.openxmlformats.org/officeDocument/2006/relationships">
   <p:cSld>
     <p:spTree>
@@ -8721,267 +9568,6 @@
                 <a:latin typeface="Calibri"/>
               </a:rPr>
               <a:t>ECE 0.0175 vs XGBoost's 0.0214 after identical recalibration. The trees keep the better Brier score, which also rewards discrimination.</a:t>
-            </a:r>
-          </a:p>
-        </p:txBody>
-      </p:sp>
-    </p:spTree>
-  </p:cSld>
-  <p:clrMapOvr>
-    <a:masterClrMapping/>
-  </p:clrMapOvr>
-</p:sld>
-</file>
-
-<file path=ppt/slides/slide8.xml><?xml version="1.0" encoding="utf-8"?>
-<p:sld xmlns:a="http://schemas.openxmlformats.org/drawingml/2006/main" xmlns:p="http://schemas.openxmlformats.org/presentationml/2006/main" xmlns:r="http://schemas.openxmlformats.org/officeDocument/2006/relationships">
-  <p:cSld>
-    <p:spTree>
-      <p:nvGrpSpPr>
-        <p:cNvPr id="1" name=""/>
-        <p:cNvGrpSpPr/>
-        <p:nvPr/>
-      </p:nvGrpSpPr>
-      <p:grpSpPr/>
-      <p:sp>
-        <p:nvSpPr>
-          <p:cNvPr id="2" name="TextBox 1"/>
-          <p:cNvSpPr txBox="1"/>
-          <p:nvPr/>
-        </p:nvSpPr>
-        <p:spPr>
-          <a:xfrm>
-            <a:off x="548640" y="347472"/>
-            <a:ext cx="11064240" cy="274320"/>
-          </a:xfrm>
-          <a:prstGeom prst="rect">
-            <a:avLst/>
-          </a:prstGeom>
-          <a:noFill/>
-        </p:spPr>
-        <p:txBody>
-          <a:bodyPr wrap="square" anchor="t" lIns="0" rIns="0" tIns="0" bIns="0">
-            <a:spAutoFit/>
-          </a:bodyPr>
-          <a:lstStyle/>
-          <a:p>
-            <a:pPr algn="l">
-              <a:lnSpc>
-                <a:spcPct val="100000"/>
-              </a:lnSpc>
-              <a:spcAft>
-                <a:spcPts val="600"/>
-              </a:spcAft>
-            </a:pPr>
-            <a:r>
-              <a:rPr sz="1300" b="1" i="0">
-                <a:solidFill>
-                  <a:srgbClr val="C99B1C"/>
-                </a:solidFill>
-                <a:latin typeface="Calibri"/>
-              </a:rPr>
-              <a:t>RESULTS 3 OF 4</a:t>
-            </a:r>
-          </a:p>
-        </p:txBody>
-      </p:sp>
-      <p:sp>
-        <p:nvSpPr>
-          <p:cNvPr id="3" name="TextBox 2"/>
-          <p:cNvSpPr txBox="1"/>
-          <p:nvPr/>
-        </p:nvSpPr>
-        <p:spPr>
-          <a:xfrm>
-            <a:off x="548640" y="621792"/>
-            <a:ext cx="11064240" cy="685800"/>
-          </a:xfrm>
-          <a:prstGeom prst="rect">
-            <a:avLst/>
-          </a:prstGeom>
-          <a:noFill/>
-        </p:spPr>
-        <p:txBody>
-          <a:bodyPr wrap="square" anchor="t" lIns="0" rIns="0" tIns="0" bIns="0">
-            <a:spAutoFit/>
-          </a:bodyPr>
-          <a:lstStyle/>
-          <a:p>
-            <a:pPr algn="l">
-              <a:lnSpc>
-                <a:spcPct val="100000"/>
-              </a:lnSpc>
-              <a:spcAft>
-                <a:spcPts val="600"/>
-              </a:spcAft>
-            </a:pPr>
-            <a:r>
-              <a:rPr sz="3200" b="1" i="0">
-                <a:solidFill>
-                  <a:srgbClr val="1B3A6B"/>
-                </a:solidFill>
-                <a:latin typeface="Calibri"/>
-              </a:rPr>
-              <a:t>Profit: the AUC Gap Becomes Money at the Cutoff</a:t>
-            </a:r>
-          </a:p>
-        </p:txBody>
-      </p:sp>
-      <p:pic>
-        <p:nvPicPr>
-          <p:cNvPr id="4" name="Picture 3" descr="fig_profit.png"/>
-          <p:cNvPicPr>
-            <a:picLocks noChangeAspect="1"/>
-          </p:cNvPicPr>
-          <p:nvPr/>
-        </p:nvPicPr>
-        <p:blipFill>
-          <a:blip r:embed="rId2"/>
-          <a:stretch>
-            <a:fillRect/>
-          </a:stretch>
-        </p:blipFill>
-        <p:spPr>
-          <a:xfrm>
-            <a:off x="548640" y="1737360"/>
-            <a:ext cx="7589520" cy="3424540"/>
-          </a:xfrm>
-          <a:prstGeom prst="rect">
-            <a:avLst/>
-          </a:prstGeom>
-        </p:spPr>
-      </p:pic>
-      <p:sp>
-        <p:nvSpPr>
-          <p:cNvPr id="5" name="TextBox 4"/>
-          <p:cNvSpPr txBox="1"/>
-          <p:nvPr/>
-        </p:nvSpPr>
-        <p:spPr>
-          <a:xfrm>
-            <a:off x="8503920" y="1828800"/>
-            <a:ext cx="3200400" cy="4023360"/>
-          </a:xfrm>
-          <a:prstGeom prst="rect">
-            <a:avLst/>
-          </a:prstGeom>
-          <a:noFill/>
-        </p:spPr>
-        <p:txBody>
-          <a:bodyPr wrap="square" anchor="t" lIns="0" rIns="0" tIns="0" bIns="0">
-            <a:spAutoFit/>
-          </a:bodyPr>
-          <a:lstStyle/>
-          <a:p>
-            <a:pPr algn="l">
-              <a:lnSpc>
-                <a:spcPct val="105000"/>
-              </a:lnSpc>
-              <a:spcAft>
-                <a:spcPts val="1100"/>
-              </a:spcAft>
-            </a:pPr>
-            <a:r>
-              <a:rPr sz="1450" b="1" i="0">
-                <a:solidFill>
-                  <a:srgbClr val="1B3A6B"/>
-                </a:solidFill>
-                <a:latin typeface="Calibri"/>
-              </a:rPr>
-              <a:t>Accepting everyone already earns  </a:t>
-            </a:r>
-            <a:r>
-              <a:rPr sz="1450" b="0" i="0">
-                <a:solidFill>
-                  <a:srgbClr val="212121"/>
-                </a:solidFill>
-                <a:latin typeface="Calibri"/>
-              </a:rPr>
-              <a:t>$705 per applicant; interest income dominates this portfolio.</a:t>
-            </a:r>
-          </a:p>
-          <a:p>
-            <a:pPr algn="l">
-              <a:lnSpc>
-                <a:spcPct val="105000"/>
-              </a:lnSpc>
-              <a:spcAft>
-                <a:spcPts val="1100"/>
-              </a:spcAft>
-            </a:pPr>
-            <a:r>
-              <a:rPr sz="1450" b="1" i="0">
-                <a:solidFill>
-                  <a:srgbClr val="1B3A6B"/>
-                </a:solidFill>
-                <a:latin typeface="Calibri"/>
-              </a:rPr>
-              <a:t>Scorecard:  </a:t>
-            </a:r>
-            <a:r>
-              <a:rPr sz="1450" b="0" i="0">
-                <a:solidFill>
-                  <a:srgbClr val="212121"/>
-                </a:solidFill>
-                <a:latin typeface="Calibri"/>
-              </a:rPr>
-              <a:t>reject the riskiest 6.7% for +1.2% profit.</a:t>
-            </a:r>
-          </a:p>
-          <a:p>
-            <a:pPr algn="l">
-              <a:lnSpc>
-                <a:spcPct val="105000"/>
-              </a:lnSpc>
-              <a:spcAft>
-                <a:spcPts val="1100"/>
-              </a:spcAft>
-            </a:pPr>
-            <a:r>
-              <a:rPr sz="1450" b="1" i="0">
-                <a:solidFill>
-                  <a:srgbClr val="1B3A6B"/>
-                </a:solidFill>
-                <a:latin typeface="Calibri"/>
-              </a:rPr>
-              <a:t>XGBoost:  </a:t>
-            </a:r>
-            <a:r>
-              <a:rPr sz="1450" b="0" i="0">
-                <a:solidFill>
-                  <a:srgbClr val="212121"/>
-                </a:solidFill>
-                <a:latin typeface="Calibri"/>
-              </a:rPr>
-              <a:t>reject 9.3% for +3.3%, that is +$14,700 per 1,000 applicants over the scorecard (+2.1%).</a:t>
-            </a:r>
-          </a:p>
-          <a:p>
-            <a:pPr algn="l">
-              <a:lnSpc>
-                <a:spcPct val="105000"/>
-              </a:lnSpc>
-              <a:spcAft>
-                <a:spcPts val="1100"/>
-              </a:spcAft>
-            </a:pPr>
-            <a:r>
-              <a:rPr sz="1450" b="1" i="0">
-                <a:solidFill>
-                  <a:srgbClr val="1B3A6B"/>
-                </a:solidFill>
-                <a:latin typeface="Calibri"/>
-              </a:rPr>
-              <a:t>Scale decides adoption:  </a:t>
-            </a:r>
-            <a:r>
-              <a:rPr sz="1450" b="0" i="0">
-                <a:solidFill>
-                  <a:srgbClr val="212121"/>
-                </a:solidFill>
-                <a:latin typeface="Calibri"/>
-              </a:rPr>
-              <a:t>a modest edge worth millions at bank volume, and nothing at credit-union volume.</a:t>
             </a:r>
           </a:p>
         </p:txBody>
@@ -9041,7 +9627,7 @@
                 </a:solidFill>
                 <a:latin typeface="Calibri"/>
               </a:rPr>
-              <a:t>RESULTS 4 OF 4</a:t>
+              <a:t>RESULTS 3 OF 4</a:t>
             </a:r>
           </a:p>
         </p:txBody>
@@ -9083,14 +9669,14 @@
                 </a:solidFill>
                 <a:latin typeface="Calibri"/>
               </a:rPr>
-              <a:t>What Did the Models Learn? Mostly the Same Thing</a:t>
+              <a:t>Profit: the AUC Gap Becomes Money at the Cutoff</a:t>
             </a:r>
           </a:p>
         </p:txBody>
       </p:sp>
       <p:pic>
         <p:nvPicPr>
-          <p:cNvPr id="4" name="Picture 3" descr="fig_importance.png"/>
+          <p:cNvPr id="4" name="Picture 3" descr="fig_profit.png"/>
           <p:cNvPicPr>
             <a:picLocks noChangeAspect="1"/>
           </p:cNvPicPr>
@@ -9105,7 +9691,7 @@
         <p:spPr>
           <a:xfrm>
             <a:off x="548640" y="1737360"/>
-            <a:ext cx="7237973" cy="3931920"/>
+            <a:ext cx="7589520" cy="3424540"/>
           </a:xfrm>
           <a:prstGeom prst="rect">
             <a:avLst/>
@@ -9120,8 +9706,8 @@
         </p:nvSpPr>
         <p:spPr>
           <a:xfrm>
-            <a:off x="7863840" y="1828800"/>
-            <a:ext cx="3840480" cy="4023360"/>
+            <a:off x="8503920" y="1828800"/>
+            <a:ext cx="3200400" cy="4023360"/>
           </a:xfrm>
           <a:prstGeom prst="rect">
             <a:avLst/>
@@ -9139,7 +9725,7 @@
                 <a:spcPct val="105000"/>
               </a:lnSpc>
               <a:spcAft>
-                <a:spcPts val="1200"/>
+                <a:spcPts val="1100"/>
               </a:spcAft>
             </a:pPr>
             <a:r>
@@ -9149,7 +9735,7 @@
                 </a:solidFill>
                 <a:latin typeface="Calibri"/>
               </a:rPr>
-              <a:t>Both families agree  </a:t>
+              <a:t>Accepting everyone already earns  </a:t>
             </a:r>
             <a:r>
               <a:rPr sz="1450" b="0" i="0">
@@ -9158,7 +9744,7 @@
                 </a:solidFill>
                 <a:latin typeface="Calibri"/>
               </a:rPr>
-              <a:t>that the platform's own pricing (interest rate, grade) carries the most signal; rank correlation 0.56.</a:t>
+              <a:t>$705 per applicant; interest income dominates this portfolio.</a:t>
             </a:r>
           </a:p>
           <a:p>
@@ -9167,7 +9753,7 @@
                 <a:spcPct val="105000"/>
               </a:lnSpc>
               <a:spcAft>
-                <a:spcPts val="1200"/>
+                <a:spcPts val="1100"/>
               </a:spcAft>
             </a:pPr>
             <a:r>
@@ -9177,7 +9763,7 @@
                 </a:solidFill>
                 <a:latin typeface="Calibri"/>
               </a:rPr>
-              <a:t>They disagree in encoding:  </a:t>
+              <a:t>Scorecard:  </a:t>
             </a:r>
             <a:r>
               <a:rPr sz="1450" b="0" i="0">
@@ -9186,7 +9772,7 @@
                 </a:solidFill>
                 <a:latin typeface="Calibri"/>
               </a:rPr>
-              <a:t>the scorecard leans on sub-grade and FICO bins; XGBoost prefers the continuous interest rate and income.</a:t>
+              <a:t>reject the riskiest 6.7% for +1.2% profit.</a:t>
             </a:r>
           </a:p>
           <a:p>
@@ -9195,7 +9781,7 @@
                 <a:spcPct val="105000"/>
               </a:lnSpc>
               <a:spcAft>
-                <a:spcPts val="1200"/>
+                <a:spcPts val="1100"/>
               </a:spcAft>
             </a:pPr>
             <a:r>
@@ -9205,7 +9791,7 @@
                 </a:solidFill>
                 <a:latin typeface="Calibri"/>
               </a:rPr>
-              <a:t>Interpretability trade-off:  </a:t>
+              <a:t>XGBoost:  </a:t>
             </a:r>
             <a:r>
               <a:rPr sz="1450" b="0" i="0">
@@ -9214,7 +9800,35 @@
                 </a:solidFill>
                 <a:latin typeface="Calibri"/>
               </a:rPr>
-              <a:t>the scorecard is a readable sum of points per applicant; the ensemble needs post-hoc explanation tools.</a:t>
+              <a:t>reject 9.3% for +3.3%, that is +$14,700 per 1,000 applicants over the scorecard (+2.1%).</a:t>
+            </a:r>
+          </a:p>
+          <a:p>
+            <a:pPr algn="l">
+              <a:lnSpc>
+                <a:spcPct val="105000"/>
+              </a:lnSpc>
+              <a:spcAft>
+                <a:spcPts val="1100"/>
+              </a:spcAft>
+            </a:pPr>
+            <a:r>
+              <a:rPr sz="1450" b="1" i="0">
+                <a:solidFill>
+                  <a:srgbClr val="1B3A6B"/>
+                </a:solidFill>
+                <a:latin typeface="Calibri"/>
+              </a:rPr>
+              <a:t>Scale decides adoption:  </a:t>
+            </a:r>
+            <a:r>
+              <a:rPr sz="1450" b="0" i="0">
+                <a:solidFill>
+                  <a:srgbClr val="212121"/>
+                </a:solidFill>
+                <a:latin typeface="Calibri"/>
+              </a:rPr>
+              <a:t>a modest edge worth millions at bank volume, and nothing at credit-union volume.</a:t>
             </a:r>
           </a:p>
         </p:txBody>

</xml_diff>